<commit_message>
Update links in L2O slides
</commit_message>
<xml_diff>
--- a/slides/L2O.pptx
+++ b/slides/L2O.pptx
@@ -1162,7 +1162,7 @@
           <a:p>
             <a:fld id="{2A6FAD2F-3255-4D6B-B7D0-3AD777FD6E16}" type="datetimeFigureOut">
               <a:rPr lang="en-US" smtClean="0"/>
-              <a:t>6/16/2026</a:t>
+              <a:t>6/16/26</a:t>
             </a:fld>
             <a:endParaRPr lang="en-US"/>
           </a:p>
@@ -1484,7 +1484,7 @@
           <a:p>
             <a:fld id="{87CA7F51-485C-4411-96B4-8DBF10CDD334}" type="datetimeFigureOut">
               <a:rPr lang="en-US" smtClean="0"/>
-              <a:t>6/16/2026</a:t>
+              <a:t>6/16/26</a:t>
             </a:fld>
             <a:endParaRPr lang="en-US"/>
           </a:p>
@@ -8504,6 +8504,28 @@
           <a:p>
             <a:pPr marL="685165" lvl="1" indent="-227965"/>
             <a:r>
+              <a:rPr lang="en-US" sz="1400" dirty="0">
+                <a:latin typeface="Arial"/>
+                <a:cs typeface="Arial"/>
+              </a:rPr>
+              <a:t>More L2O examples: </a:t>
+            </a:r>
+            <a:r>
+              <a:rPr lang="en-US" sz="1400" dirty="0">
+                <a:latin typeface="Arial"/>
+                <a:cs typeface="Arial"/>
+                <a:hlinkClick r:id="rId2"/>
+              </a:rPr>
+              <a:t>https://github.com/pnnl/neuromancer</a:t>
+            </a:r>
+            <a:endParaRPr lang="en-US" sz="1400" dirty="0">
+              <a:latin typeface="Arial"/>
+              <a:cs typeface="Arial"/>
+            </a:endParaRPr>
+          </a:p>
+          <a:p>
+            <a:pPr marL="685165" lvl="1" indent="-227965"/>
+            <a:r>
               <a:rPr lang="en-US" sz="1400" dirty="0" err="1">
                 <a:latin typeface="Arial"/>
                 <a:cs typeface="Arial"/>
@@ -8521,31 +8543,16 @@
               <a:rPr lang="en-US" sz="1400" dirty="0">
                 <a:latin typeface="Arial"/>
                 <a:cs typeface="Arial"/>
-                <a:hlinkClick r:id="rId2"/>
+                <a:hlinkClick r:id="rId3"/>
               </a:rPr>
               <a:t>https://pimlxplore.nxtlab.org/</a:t>
-            </a:r>
-            <a:endParaRPr lang="en-US" sz="1400" dirty="0">
-              <a:latin typeface="Arial"/>
-              <a:cs typeface="Arial"/>
-            </a:endParaRPr>
-          </a:p>
-          <a:p>
-            <a:pPr marL="685165" lvl="1" indent="-227965"/>
-            <a:r>
-              <a:rPr lang="en-US" sz="1400" dirty="0">
-                <a:latin typeface="Arial"/>
-                <a:cs typeface="Arial"/>
-                <a:hlinkClick r:id="rId3"/>
-              </a:rPr>
-              <a:t>https://nxtlab.org/</a:t>
             </a:r>
             <a:r>
               <a:rPr lang="en-US" sz="1400" dirty="0">
                 <a:latin typeface="Arial"/>
                 <a:cs typeface="Arial"/>
               </a:rPr>
-              <a:t> </a:t>
+              <a:t>  </a:t>
             </a:r>
           </a:p>
           <a:p>
@@ -8575,6 +8582,31 @@
               </a:rPr>
               <a:t>nxt@ucf.edu</a:t>
             </a:r>
+            <a:r>
+              <a:rPr lang="en-US" sz="1600" dirty="0">
+                <a:ea typeface="Tahoma"/>
+              </a:rPr>
+              <a:t> </a:t>
+            </a:r>
+            <a:br>
+              <a:rPr lang="en-US" sz="1600" dirty="0">
+                <a:ea typeface="Tahoma"/>
+              </a:rPr>
+            </a:br>
+            <a:r>
+              <a:rPr lang="en-US" sz="1600" dirty="0">
+                <a:ea typeface="Tahoma"/>
+              </a:rPr>
+              <a:t>		     </a:t>
+            </a:r>
+            <a:r>
+              <a:rPr lang="en-US" sz="1600" dirty="0">
+                <a:latin typeface="Arial"/>
+                <a:cs typeface="Arial"/>
+                <a:hlinkClick r:id="rId5"/>
+              </a:rPr>
+              <a:t>https://nxtlab.org/</a:t>
+            </a:r>
             <a:endParaRPr lang="en-US" sz="1600" dirty="0">
               <a:ea typeface="Tahoma"/>
             </a:endParaRPr>
@@ -8596,7 +8628,7 @@
           <p:nvPr/>
         </p:nvPicPr>
         <p:blipFill rotWithShape="1">
-          <a:blip r:embed="rId5">
+          <a:blip r:embed="rId6">
             <a:extLst>
               <a:ext uri="{28A0092B-C50C-407E-A947-70E740481C1C}">
                 <a14:useLocalDpi xmlns:a14="http://schemas.microsoft.com/office/drawing/2010/main" val="0"/>
@@ -8608,8 +8640,8 @@
         </p:blipFill>
         <p:spPr>
           <a:xfrm>
-            <a:off x="1495148" y="3586512"/>
-            <a:ext cx="6139958" cy="1389182"/>
+            <a:off x="1723545" y="3638187"/>
+            <a:ext cx="5683164" cy="1285832"/>
           </a:xfrm>
           <a:prstGeom prst="rect">
             <a:avLst/>
@@ -18806,7 +18838,7 @@
         <p:spPr>
           <a:xfrm>
             <a:off x="2278856" y="3836194"/>
-            <a:ext cx="5092950" cy="584775"/>
+            <a:ext cx="4999022" cy="584775"/>
           </a:xfrm>
           <a:prstGeom prst="rect">
             <a:avLst/>
@@ -18832,7 +18864,7 @@
               <a:rPr lang="en-US" sz="1600" b="1" dirty="0"/>
               <a:t> </a:t>
             </a:r>
-            <a:endParaRPr lang="en-US" sz="1600" b="1">
+            <a:endParaRPr lang="en-US" sz="1600" b="1" dirty="0">
               <a:ea typeface="Tahoma"/>
               <a:cs typeface="Tahoma"/>
             </a:endParaRPr>

</xml_diff>